<commit_message>
Update Principal Code Challenge
</commit_message>
<xml_diff>
--- a/3. .NET Internals/Internals.pptx
+++ b/3. .NET Internals/Internals.pptx
@@ -1111,7 +1111,7 @@
           </a:p>
           <a:p>
             <a:r>
-              <a:t>• Controller.HttpContext (and User, Request, Response): a property on the controller instance, assigned by MVC when the controller is created. It is an ordinary object reference. It is available inside a suppressed-flow Task.Run because the lambda captured "this", not because anything flowed. (Holding onto it after the request ends is a bug; the object is recycled.)</a:t>
+              <a:t>• Controller.HttpContext (and User, Request, Response): a property on the controller instance that reads the ControllerContext MVC assigned when it created the controller. It is an ordinary object reference. It is available inside a suppressed-flow Task.Run because the lambda captured "this", not because anything flowed. (Holding onto it after the request ends is a bug; the object is recycled.)</a:t>
             </a:r>
           </a:p>
           <a:p>
@@ -1124,7 +1124,7 @@
           </a:p>
           <a:p>
             <a:r>
-              <a:t>Why this matters for the challenge: in the "3. Principal" log output the IHttpContextAccessor.HttpContext column becomes &lt;null&gt; inside the suppressed Task.Run while the Controller.HttpContext column stays "available". Same HttpContext object, two very different delivery mechanisms.</a:t>
+              <a:t>Why this matters for the challenge: in the "3. Principal" results table the httpContextAccessor.HttpContext?.User column shows null at checkpoint 4 (the Task.Run started with flow suppressed) while the HttpContext.User column still shows your name. Same HttpContext object, two very different delivery mechanisms.</a:t>
             </a:r>
           </a:p>
           <a:p>
@@ -2058,7 +2058,7 @@
           <a:lstStyle/>
           <a:p>
             <a:r>
-              <a:t>.NET 8 added an overload, task.ConfigureAwait(ConfigureAwaitOptions), a flags enum that replaces the true/false switch with independent knobs. The "3. Principal" sample uses it, so let's decode it.</a:t>
+              <a:t>.NET 8 added an overload, task.ConfigureAwait(ConfigureAwaitOptions), a flags enum that replaces the true/false switch with independent knobs. The "4. SynchronizationContext" HackerNews sample uses it (ConfigureAwaitOptions.None | ConfigureAwaitOptions.SuppressThrowing), so let's decode it.</a:t>
             </a:r>
           </a:p>
           <a:p>
@@ -2107,12 +2107,12 @@
           </a:p>
           <a:p>
             <a:r>
-              <a:t>• "3. Principal" awaits SignInAsync with ConfigureAwaitOptions.ForceYielding | ConfigureAwaitOptions.None. None is zero, so it is written only for readability; the point is that the "After await" log line is GUARANTEED to run as a scheduled Thread Pool continuation rather than synchronously, so it typically lands on a different thread, which makes the Thread.CurrentPrincipal result meaningful.</a:t>
-            </a:r>
-          </a:p>
-          <a:p>
-            <a:r>
-              <a:t>• "4. SynchronizationContext" uses plain ConfigureAwait(false). If GetTopStoryIDs returns cached data, or a story request completes instantly, the continuation is synchronous and SynchronizationContext.Current may be unchanged, which is exactly what step 6 of the challenge asks you to explain.</a:t>
+              <a:t>• "3. Principal" needs the guarantee ForceYielding gives and gets it with await Task.Yield(), which never completes synchronously: checkpoint 2 always runs as a scheduled Thread Pool continuation rather than inline, so it typically lands on a different thread, which makes the Thread.CurrentPrincipal result meaningful.</a:t>
+            </a:r>
+          </a:p>
+          <a:p>
+            <a:r>
+              <a:t>• "4. SynchronizationContext" uses plain ConfigureAwait(false) for its Hacker News requests. If GetTopStoryIDs returns cached data, or a story request completes instantly, the continuation is synchronous and SynchronizationContext.Current may be unchanged, which is exactly what step 6 of the challenge asks you to explain.</a:t>
             </a:r>
           </a:p>
           <a:p>
@@ -2219,7 +2219,7 @@
           </a:p>
           <a:p>
             <a:r>
-              <a:t>3. Not ambient at all. Some values look like they "flowed," but they were never attached to a thread or a context in the first place. The controller's HttpContext property is a field on the controller object; the "principal" local in the Login action is hoisted by the compiler into the async state machine (remember module 1). Any code that holds a reference can read them, on any thread, with or without ExecutionContext flow. Seeing them after an await proves the state machine kept its captured variables, not that .NET flowed anything.</a:t>
+              <a:t>3. Not ambient at all. Some values look like they "flowed," but they were never attached to a thread or a context in the first place. The controller's HttpContext property is read from the controller object; the signedInUser local in RunExperiment() is captured by the Observe local function, so the compiler stores it in a closure object that the async state machine and both Task.Run lambdas reference (remember module 1). Any code that holds a reference can read them, on any thread, with or without ExecutionContext flow. Seeing them after an await proves the state machine kept its captured variables, not that .NET flowed anything.</a:t>
             </a:r>
           </a:p>
           <a:p>
@@ -2227,7 +2227,7 @@
           </a:p>
           <a:p>
             <a:r>
-              <a:t>Why this matters for the challenges: the "3. Principal" log lines are designed around exactly these buckets. After the forced thread switch, all four values are available. Inside Task.Run with flow suppressed, the two AsyncLocal-backed values (Thread.CurrentPrincipal and IHttpContextAccessor.HttpContext) are &lt;null&gt;, while Controller.HttpContext and the principal local are still available. Read the columns, not the rows.</a:t>
+              <a:t>Why this matters for the challenges: the "3. Principal" results table is designed around exactly these buckets. After the await at checkpoint 2, usually on a different thread, all four columns show your name. At checkpoint 4, inside Task.Run with flow suppressed, the two AsyncLocal-backed columns (Thread.CurrentPrincipal and httpContextAccessor.HttpContext?.User) show null, while HttpContext.User and the signedInUser local still show your name. Read the columns, not the rows.</a:t>
             </a:r>
           </a:p>
           <a:p>
@@ -3100,7 +3100,7 @@
           </a:p>
           <a:p>
             <a:r>
-              <a:t>Why this matters for the challenges: steps 7 and 8 of "2. ExecutionContext" ("why does the suppressed task see default values?" and "why is the task awaited only after leaving the using block?") are answered by this slide, and so is the third log line in "3. Principal".</a:t>
+              <a:t>Why this matters for the challenges: steps 7 and 8 of "2. ExecutionContext" ("why does the suppressed task see default values?" and "why is the task awaited only after leaving the using block?") are answered by this slide, and so is checkpoint 4 in "3. Principal".</a:t>
             </a:r>
           </a:p>
           <a:p>
@@ -3555,93 +3555,13 @@
           <a:p>
             <a:r>
               <a:rPr dirty="0"/>
-              <a:t>• Identity: an </a:t>
-            </a:r>
-            <a:r>
-              <a:rPr dirty="0" err="1"/>
-              <a:t>IIdentity</a:t>
-            </a:r>
+              <a:t>• Identity: an IIdentity answers "who is this?" (Name, AuthenticationType, IsAuthenticated). ClaimsIdentity is the modern implementation: a bag of Claims such as Name = "Ada" or Role = "Admin". The sample's identity holds a single Name claim: the name you type when you sign in.</a:t>
+            </a:r>
+          </a:p>
+          <a:p>
             <a:r>
               <a:rPr dirty="0"/>
-              <a:t> answers "who is this?" (Name, </a:t>
-            </a:r>
-            <a:r>
-              <a:rPr dirty="0" err="1"/>
-              <a:t>AuthenticationType</a:t>
-            </a:r>
-            <a:r>
-              <a:rPr dirty="0"/>
-              <a:t>, </a:t>
-            </a:r>
-            <a:r>
-              <a:rPr dirty="0" err="1"/>
-              <a:t>IsAuthenticated</a:t>
-            </a:r>
-            <a:r>
-              <a:rPr dirty="0"/>
-              <a:t>). </a:t>
-            </a:r>
-            <a:r>
-              <a:rPr dirty="0" err="1"/>
-              <a:t>ClaimsIdentity</a:t>
-            </a:r>
-            <a:r>
-              <a:rPr dirty="0"/>
-              <a:t> is the modern implementation: a bag of Claims such as Name = "</a:t>
-            </a:r>
-            <a:r>
-              <a:rPr dirty="0" err="1"/>
-              <a:t>testuser</a:t>
-            </a:r>
-            <a:r>
-              <a:rPr dirty="0"/>
-              <a:t>" and Role = "Admin".</a:t>
-            </a:r>
-          </a:p>
-          <a:p>
-            <a:r>
-              <a:rPr dirty="0"/>
-              <a:t>• Roles and Claims: an </a:t>
-            </a:r>
-            <a:r>
-              <a:rPr dirty="0" err="1"/>
-              <a:t>IPrincipal</a:t>
-            </a:r>
-            <a:r>
-              <a:rPr dirty="0"/>
-              <a:t> wraps an identity and answers "what can they do?" via </a:t>
-            </a:r>
-            <a:r>
-              <a:rPr dirty="0" err="1"/>
-              <a:t>IsInRole</a:t>
-            </a:r>
-            <a:r>
-              <a:rPr dirty="0"/>
-              <a:t>(...). </a:t>
-            </a:r>
-            <a:r>
-              <a:rPr dirty="0" err="1"/>
-              <a:t>ClaimsPrincipal</a:t>
-            </a:r>
-            <a:r>
-              <a:rPr dirty="0"/>
-              <a:t> is the modern implementation and can hold several identities. The sample builds one with new </a:t>
-            </a:r>
-            <a:r>
-              <a:rPr dirty="0" err="1"/>
-              <a:t>ClaimsPrincipal</a:t>
-            </a:r>
-            <a:r>
-              <a:rPr dirty="0"/>
-              <a:t>(new </a:t>
-            </a:r>
-            <a:r>
-              <a:rPr dirty="0" err="1"/>
-              <a:t>ClaimsIdentity</a:t>
-            </a:r>
-            <a:r>
-              <a:rPr dirty="0"/>
-              <a:t>(claims, scheme)).</a:t>
+              <a:t>• Roles and Claims: an IPrincipal wraps an identity and answers "what can they do?" via IsInRole(...). ClaimsPrincipal is the modern implementation and can hold several identities. In the sample, AccountController.Login wraps the ClaimsIdentity in a new ClaimsPrincipal and signs in with it.</a:t>
             </a:r>
           </a:p>
           <a:p>
@@ -3662,134 +3582,22 @@
           <a:p>
             <a:r>
               <a:rPr dirty="0"/>
-              <a:t>• </a:t>
-            </a:r>
-            <a:r>
-              <a:rPr dirty="0" err="1"/>
-              <a:t>Thread.CurrentPrincipal</a:t>
-            </a:r>
+              <a:t>• Thread.CurrentPrincipal: the "ambient" principal for the current logical operation. It is typed as IPrincipal; the sample stores a ClaimsPrincipal in it. In .NET Core this property is backed by AsyncLocal&lt;T&gt;, so it rides on the ExecutionContext and survives an await, even when the continuation lands on a different thread. It is null unless something set it.</a:t>
+            </a:r>
+          </a:p>
+          <a:p>
             <a:r>
               <a:rPr dirty="0"/>
-              <a:t> (first code screenshot): the "ambient" principal for the current logical operation. The screenshot uses the older </a:t>
-            </a:r>
-            <a:r>
-              <a:rPr dirty="0" err="1"/>
-              <a:t>GenericPrincipal</a:t>
-            </a:r>
+              <a:t>• HttpContext.User, exposed as the controller's User property (the code screenshot): the request's principal, populated by the authentication middleware from the cookie or token. In ASP.NET Core this is the one you should normally use. ASP.NET Core never sets Thread.CurrentPrincipal for you. In the sample, checkpoint 1 shows it as null while HttpContext.User already holds the signed-in user, which is why RunExperiment() then assigns it by hand.</a:t>
+            </a:r>
+          </a:p>
+          <a:p>
+            <a:endParaRPr dirty="0"/>
+          </a:p>
+          <a:p>
             <a:r>
               <a:rPr dirty="0"/>
-              <a:t> / </a:t>
-            </a:r>
-            <a:r>
-              <a:rPr dirty="0" err="1"/>
-              <a:t>WindowsIdentity</a:t>
-            </a:r>
-            <a:r>
-              <a:rPr dirty="0"/>
-              <a:t> pair; the sample uses </a:t>
-            </a:r>
-            <a:r>
-              <a:rPr dirty="0" err="1"/>
-              <a:t>ClaimsPrincipal</a:t>
-            </a:r>
-            <a:r>
-              <a:rPr dirty="0"/>
-              <a:t>, and both implement </a:t>
-            </a:r>
-            <a:r>
-              <a:rPr dirty="0" err="1"/>
-              <a:t>IPrincipal</a:t>
-            </a:r>
-            <a:r>
-              <a:rPr dirty="0"/>
-              <a:t>. In .NET Core this property is backed by </a:t>
-            </a:r>
-            <a:r>
-              <a:rPr dirty="0" err="1"/>
-              <a:t>AsyncLocal</a:t>
-            </a:r>
-            <a:r>
-              <a:rPr dirty="0"/>
-              <a:t>&lt;T&gt;, so it rides on the </a:t>
-            </a:r>
-            <a:r>
-              <a:rPr dirty="0" err="1"/>
-              <a:t>ExecutionContext</a:t>
-            </a:r>
-            <a:r>
-              <a:rPr dirty="0"/>
-              <a:t> and survives an await, even when the continuation lands on a different thread. It is null unless something set it.</a:t>
-            </a:r>
-          </a:p>
-          <a:p>
-            <a:r>
-              <a:rPr dirty="0"/>
-              <a:t>• </a:t>
-            </a:r>
-            <a:r>
-              <a:rPr dirty="0" err="1"/>
-              <a:t>HttpContext.User</a:t>
-            </a:r>
-            <a:r>
-              <a:rPr dirty="0"/>
-              <a:t>, exposed as the controller's User property (second screenshot): the request's principal, populated by the authentication middleware from the cookie or token. In ASP.NET Core this is the one you should normally use. ASP.NET Core never sets </a:t>
-            </a:r>
-            <a:r>
-              <a:rPr dirty="0" err="1"/>
-              <a:t>Thread.CurrentPrincipal</a:t>
-            </a:r>
-            <a:r>
-              <a:rPr dirty="0"/>
-              <a:t> for you, which is why the sample assigns it by hand.</a:t>
-            </a:r>
-          </a:p>
-          <a:p>
-            <a:endParaRPr dirty="0"/>
-          </a:p>
-          <a:p>
-            <a:r>
-              <a:rPr dirty="0"/>
-              <a:t>Why this matters for the challenge: the "3. Principal" sample sets </a:t>
-            </a:r>
-            <a:r>
-              <a:rPr dirty="0" err="1"/>
-              <a:t>Thread.CurrentPrincipal</a:t>
-            </a:r>
-            <a:r>
-              <a:rPr dirty="0"/>
-              <a:t>, calls </a:t>
-            </a:r>
-            <a:r>
-              <a:rPr dirty="0" err="1"/>
-              <a:t>HttpContext.SignInAsync</a:t>
-            </a:r>
-            <a:r>
-              <a:rPr dirty="0"/>
-              <a:t>(...) (which issues the authentication cookie) with an await that is forced to complete asynchronously (</a:t>
-            </a:r>
-            <a:r>
-              <a:rPr dirty="0" err="1"/>
-              <a:t>ConfigureAwaitOptions.ForceYielding</a:t>
-            </a:r>
-            <a:r>
-              <a:rPr dirty="0"/>
-              <a:t>, covered later), so the rest of the method runs as a scheduled Thread Pool work item, typically on a different thread. You will see the principal survive that switch, and then disappear inside a </a:t>
-            </a:r>
-            <a:r>
-              <a:rPr dirty="0" err="1"/>
-              <a:t>Task.Run</a:t>
-            </a:r>
-            <a:r>
-              <a:rPr dirty="0"/>
-              <a:t>(...) that was started with </a:t>
-            </a:r>
-            <a:r>
-              <a:rPr dirty="0" err="1"/>
-              <a:t>ExecutionContext</a:t>
-            </a:r>
-            <a:r>
-              <a:rPr dirty="0"/>
-              <a:t> flow suppressed.</a:t>
+              <a:t>Why this matters for the challenge: in "3. Principal" you sign in with your own name, and HomeController.RunExperiment() copies HttpContext.User into Thread.CurrentPrincipal, then awaits Task.Yield(). That await never completes synchronously (ConfigureAwaitOptions.ForceYielding, covered later, gives an awaited Task the same guarantee), so the rest of the method runs as a scheduled Thread Pool work item, typically on a different thread. The results table shows the principal survive that switch, flow into Task.Run(...), and come back null inside a Task.Run(...) that was started with ExecutionContext flow suppressed.</a:t>
             </a:r>
           </a:p>
           <a:p>

</xml_diff>

<commit_message>
Update Principal Code Challenge (#23)
</commit_message>
<xml_diff>
--- a/3. .NET Internals/Internals.pptx
+++ b/3. .NET Internals/Internals.pptx
@@ -1111,7 +1111,7 @@
           </a:p>
           <a:p>
             <a:r>
-              <a:t>• Controller.HttpContext (and User, Request, Response): a property on the controller instance, assigned by MVC when the controller is created. It is an ordinary object reference. It is available inside a suppressed-flow Task.Run because the lambda captured "this", not because anything flowed. (Holding onto it after the request ends is a bug; the object is recycled.)</a:t>
+              <a:t>• Controller.HttpContext (and User, Request, Response): a property on the controller instance that reads the ControllerContext MVC assigned when it created the controller. It is an ordinary object reference. It is available inside a suppressed-flow Task.Run because the lambda captured "this", not because anything flowed. (Holding onto it after the request ends is a bug; the object is recycled.)</a:t>
             </a:r>
           </a:p>
           <a:p>
@@ -1124,7 +1124,7 @@
           </a:p>
           <a:p>
             <a:r>
-              <a:t>Why this matters for the challenge: in the "3. Principal" log output the IHttpContextAccessor.HttpContext column becomes &lt;null&gt; inside the suppressed Task.Run while the Controller.HttpContext column stays "available". Same HttpContext object, two very different delivery mechanisms.</a:t>
+              <a:t>Why this matters for the challenge: in the "3. Principal" results table the httpContextAccessor.HttpContext?.User column shows null at checkpoint 4 (the Task.Run started with flow suppressed) while the HttpContext.User column still shows your name. Same HttpContext object, two very different delivery mechanisms.</a:t>
             </a:r>
           </a:p>
           <a:p>
@@ -2058,7 +2058,7 @@
           <a:lstStyle/>
           <a:p>
             <a:r>
-              <a:t>.NET 8 added an overload, task.ConfigureAwait(ConfigureAwaitOptions), a flags enum that replaces the true/false switch with independent knobs. The "3. Principal" sample uses it, so let's decode it.</a:t>
+              <a:t>.NET 8 added an overload, task.ConfigureAwait(ConfigureAwaitOptions), a flags enum that replaces the true/false switch with independent knobs. The "4. SynchronizationContext" HackerNews sample uses it (ConfigureAwaitOptions.None | ConfigureAwaitOptions.SuppressThrowing), so let's decode it.</a:t>
             </a:r>
           </a:p>
           <a:p>
@@ -2107,12 +2107,12 @@
           </a:p>
           <a:p>
             <a:r>
-              <a:t>• "3. Principal" awaits SignInAsync with ConfigureAwaitOptions.ForceYielding | ConfigureAwaitOptions.None. None is zero, so it is written only for readability; the point is that the "After await" log line is GUARANTEED to run as a scheduled Thread Pool continuation rather than synchronously, so it typically lands on a different thread, which makes the Thread.CurrentPrincipal result meaningful.</a:t>
-            </a:r>
-          </a:p>
-          <a:p>
-            <a:r>
-              <a:t>• "4. SynchronizationContext" uses plain ConfigureAwait(false). If GetTopStoryIDs returns cached data, or a story request completes instantly, the continuation is synchronous and SynchronizationContext.Current may be unchanged, which is exactly what step 6 of the challenge asks you to explain.</a:t>
+              <a:t>• "3. Principal" needs the guarantee ForceYielding gives and gets it with await Task.Yield(), which never completes synchronously: checkpoint 2 always runs as a scheduled Thread Pool continuation rather than inline, so it typically lands on a different thread, which makes the Thread.CurrentPrincipal result meaningful.</a:t>
+            </a:r>
+          </a:p>
+          <a:p>
+            <a:r>
+              <a:t>• "4. SynchronizationContext" uses plain ConfigureAwait(false) for its Hacker News requests. If GetTopStoryIDs returns cached data, or a story request completes instantly, the continuation is synchronous and SynchronizationContext.Current may be unchanged, which is exactly what step 6 of the challenge asks you to explain.</a:t>
             </a:r>
           </a:p>
           <a:p>
@@ -2219,7 +2219,7 @@
           </a:p>
           <a:p>
             <a:r>
-              <a:t>3. Not ambient at all. Some values look like they "flowed," but they were never attached to a thread or a context in the first place. The controller's HttpContext property is a field on the controller object; the "principal" local in the Login action is hoisted by the compiler into the async state machine (remember module 1). Any code that holds a reference can read them, on any thread, with or without ExecutionContext flow. Seeing them after an await proves the state machine kept its captured variables, not that .NET flowed anything.</a:t>
+              <a:t>3. Not ambient at all. Some values look like they "flowed," but they were never attached to a thread or a context in the first place. The controller's HttpContext property is read from the controller object; the signedInUser local in RunExperiment() is captured by the Observe local function, so the compiler stores it in a closure object that the async state machine and both Task.Run lambdas reference (remember module 1). Any code that holds a reference can read them, on any thread, with or without ExecutionContext flow. Seeing them after an await proves the state machine kept its captured variables, not that .NET flowed anything.</a:t>
             </a:r>
           </a:p>
           <a:p>
@@ -2227,7 +2227,7 @@
           </a:p>
           <a:p>
             <a:r>
-              <a:t>Why this matters for the challenges: the "3. Principal" log lines are designed around exactly these buckets. After the forced thread switch, all four values are available. Inside Task.Run with flow suppressed, the two AsyncLocal-backed values (Thread.CurrentPrincipal and IHttpContextAccessor.HttpContext) are &lt;null&gt;, while Controller.HttpContext and the principal local are still available. Read the columns, not the rows.</a:t>
+              <a:t>Why this matters for the challenges: the "3. Principal" results table is designed around exactly these buckets. After the await at checkpoint 2, usually on a different thread, all four columns show your name. At checkpoint 4, inside Task.Run with flow suppressed, the two AsyncLocal-backed columns (Thread.CurrentPrincipal and httpContextAccessor.HttpContext?.User) show null, while HttpContext.User and the signedInUser local still show your name. Read the columns, not the rows.</a:t>
             </a:r>
           </a:p>
           <a:p>
@@ -3100,7 +3100,7 @@
           </a:p>
           <a:p>
             <a:r>
-              <a:t>Why this matters for the challenges: steps 7 and 8 of "2. ExecutionContext" ("why does the suppressed task see default values?" and "why is the task awaited only after leaving the using block?") are answered by this slide, and so is the third log line in "3. Principal".</a:t>
+              <a:t>Why this matters for the challenges: steps 7 and 8 of "2. ExecutionContext" ("why does the suppressed task see default values?" and "why is the task awaited only after leaving the using block?") are answered by this slide, and so is checkpoint 4 in "3. Principal".</a:t>
             </a:r>
           </a:p>
           <a:p>
@@ -3555,93 +3555,13 @@
           <a:p>
             <a:r>
               <a:rPr dirty="0"/>
-              <a:t>• Identity: an </a:t>
-            </a:r>
-            <a:r>
-              <a:rPr dirty="0" err="1"/>
-              <a:t>IIdentity</a:t>
-            </a:r>
+              <a:t>• Identity: an IIdentity answers "who is this?" (Name, AuthenticationType, IsAuthenticated). ClaimsIdentity is the modern implementation: a bag of Claims such as Name = "Ada" or Role = "Admin". The sample's identity holds a single Name claim: the name you type when you sign in.</a:t>
+            </a:r>
+          </a:p>
+          <a:p>
             <a:r>
               <a:rPr dirty="0"/>
-              <a:t> answers "who is this?" (Name, </a:t>
-            </a:r>
-            <a:r>
-              <a:rPr dirty="0" err="1"/>
-              <a:t>AuthenticationType</a:t>
-            </a:r>
-            <a:r>
-              <a:rPr dirty="0"/>
-              <a:t>, </a:t>
-            </a:r>
-            <a:r>
-              <a:rPr dirty="0" err="1"/>
-              <a:t>IsAuthenticated</a:t>
-            </a:r>
-            <a:r>
-              <a:rPr dirty="0"/>
-              <a:t>). </a:t>
-            </a:r>
-            <a:r>
-              <a:rPr dirty="0" err="1"/>
-              <a:t>ClaimsIdentity</a:t>
-            </a:r>
-            <a:r>
-              <a:rPr dirty="0"/>
-              <a:t> is the modern implementation: a bag of Claims such as Name = "</a:t>
-            </a:r>
-            <a:r>
-              <a:rPr dirty="0" err="1"/>
-              <a:t>testuser</a:t>
-            </a:r>
-            <a:r>
-              <a:rPr dirty="0"/>
-              <a:t>" and Role = "Admin".</a:t>
-            </a:r>
-          </a:p>
-          <a:p>
-            <a:r>
-              <a:rPr dirty="0"/>
-              <a:t>• Roles and Claims: an </a:t>
-            </a:r>
-            <a:r>
-              <a:rPr dirty="0" err="1"/>
-              <a:t>IPrincipal</a:t>
-            </a:r>
-            <a:r>
-              <a:rPr dirty="0"/>
-              <a:t> wraps an identity and answers "what can they do?" via </a:t>
-            </a:r>
-            <a:r>
-              <a:rPr dirty="0" err="1"/>
-              <a:t>IsInRole</a:t>
-            </a:r>
-            <a:r>
-              <a:rPr dirty="0"/>
-              <a:t>(...). </a:t>
-            </a:r>
-            <a:r>
-              <a:rPr dirty="0" err="1"/>
-              <a:t>ClaimsPrincipal</a:t>
-            </a:r>
-            <a:r>
-              <a:rPr dirty="0"/>
-              <a:t> is the modern implementation and can hold several identities. The sample builds one with new </a:t>
-            </a:r>
-            <a:r>
-              <a:rPr dirty="0" err="1"/>
-              <a:t>ClaimsPrincipal</a:t>
-            </a:r>
-            <a:r>
-              <a:rPr dirty="0"/>
-              <a:t>(new </a:t>
-            </a:r>
-            <a:r>
-              <a:rPr dirty="0" err="1"/>
-              <a:t>ClaimsIdentity</a:t>
-            </a:r>
-            <a:r>
-              <a:rPr dirty="0"/>
-              <a:t>(claims, scheme)).</a:t>
+              <a:t>• Roles and Claims: an IPrincipal wraps an identity and answers "what can they do?" via IsInRole(...). ClaimsPrincipal is the modern implementation and can hold several identities. In the sample, AccountController.Login wraps the ClaimsIdentity in a new ClaimsPrincipal and signs in with it.</a:t>
             </a:r>
           </a:p>
           <a:p>
@@ -3662,134 +3582,22 @@
           <a:p>
             <a:r>
               <a:rPr dirty="0"/>
-              <a:t>• </a:t>
-            </a:r>
-            <a:r>
-              <a:rPr dirty="0" err="1"/>
-              <a:t>Thread.CurrentPrincipal</a:t>
-            </a:r>
+              <a:t>• Thread.CurrentPrincipal: the "ambient" principal for the current logical operation. It is typed as IPrincipal; the sample stores a ClaimsPrincipal in it. In .NET Core this property is backed by AsyncLocal&lt;T&gt;, so it rides on the ExecutionContext and survives an await, even when the continuation lands on a different thread. It is null unless something set it.</a:t>
+            </a:r>
+          </a:p>
+          <a:p>
             <a:r>
               <a:rPr dirty="0"/>
-              <a:t> (first code screenshot): the "ambient" principal for the current logical operation. The screenshot uses the older </a:t>
-            </a:r>
-            <a:r>
-              <a:rPr dirty="0" err="1"/>
-              <a:t>GenericPrincipal</a:t>
-            </a:r>
+              <a:t>• HttpContext.User, exposed as the controller's User property (the code screenshot): the request's principal, populated by the authentication middleware from the cookie or token. In ASP.NET Core this is the one you should normally use. ASP.NET Core never sets Thread.CurrentPrincipal for you. In the sample, checkpoint 1 shows it as null while HttpContext.User already holds the signed-in user, which is why RunExperiment() then assigns it by hand.</a:t>
+            </a:r>
+          </a:p>
+          <a:p>
+            <a:endParaRPr dirty="0"/>
+          </a:p>
+          <a:p>
             <a:r>
               <a:rPr dirty="0"/>
-              <a:t> / </a:t>
-            </a:r>
-            <a:r>
-              <a:rPr dirty="0" err="1"/>
-              <a:t>WindowsIdentity</a:t>
-            </a:r>
-            <a:r>
-              <a:rPr dirty="0"/>
-              <a:t> pair; the sample uses </a:t>
-            </a:r>
-            <a:r>
-              <a:rPr dirty="0" err="1"/>
-              <a:t>ClaimsPrincipal</a:t>
-            </a:r>
-            <a:r>
-              <a:rPr dirty="0"/>
-              <a:t>, and both implement </a:t>
-            </a:r>
-            <a:r>
-              <a:rPr dirty="0" err="1"/>
-              <a:t>IPrincipal</a:t>
-            </a:r>
-            <a:r>
-              <a:rPr dirty="0"/>
-              <a:t>. In .NET Core this property is backed by </a:t>
-            </a:r>
-            <a:r>
-              <a:rPr dirty="0" err="1"/>
-              <a:t>AsyncLocal</a:t>
-            </a:r>
-            <a:r>
-              <a:rPr dirty="0"/>
-              <a:t>&lt;T&gt;, so it rides on the </a:t>
-            </a:r>
-            <a:r>
-              <a:rPr dirty="0" err="1"/>
-              <a:t>ExecutionContext</a:t>
-            </a:r>
-            <a:r>
-              <a:rPr dirty="0"/>
-              <a:t> and survives an await, even when the continuation lands on a different thread. It is null unless something set it.</a:t>
-            </a:r>
-          </a:p>
-          <a:p>
-            <a:r>
-              <a:rPr dirty="0"/>
-              <a:t>• </a:t>
-            </a:r>
-            <a:r>
-              <a:rPr dirty="0" err="1"/>
-              <a:t>HttpContext.User</a:t>
-            </a:r>
-            <a:r>
-              <a:rPr dirty="0"/>
-              <a:t>, exposed as the controller's User property (second screenshot): the request's principal, populated by the authentication middleware from the cookie or token. In ASP.NET Core this is the one you should normally use. ASP.NET Core never sets </a:t>
-            </a:r>
-            <a:r>
-              <a:rPr dirty="0" err="1"/>
-              <a:t>Thread.CurrentPrincipal</a:t>
-            </a:r>
-            <a:r>
-              <a:rPr dirty="0"/>
-              <a:t> for you, which is why the sample assigns it by hand.</a:t>
-            </a:r>
-          </a:p>
-          <a:p>
-            <a:endParaRPr dirty="0"/>
-          </a:p>
-          <a:p>
-            <a:r>
-              <a:rPr dirty="0"/>
-              <a:t>Why this matters for the challenge: the "3. Principal" sample sets </a:t>
-            </a:r>
-            <a:r>
-              <a:rPr dirty="0" err="1"/>
-              <a:t>Thread.CurrentPrincipal</a:t>
-            </a:r>
-            <a:r>
-              <a:rPr dirty="0"/>
-              <a:t>, calls </a:t>
-            </a:r>
-            <a:r>
-              <a:rPr dirty="0" err="1"/>
-              <a:t>HttpContext.SignInAsync</a:t>
-            </a:r>
-            <a:r>
-              <a:rPr dirty="0"/>
-              <a:t>(...) (which issues the authentication cookie) with an await that is forced to complete asynchronously (</a:t>
-            </a:r>
-            <a:r>
-              <a:rPr dirty="0" err="1"/>
-              <a:t>ConfigureAwaitOptions.ForceYielding</a:t>
-            </a:r>
-            <a:r>
-              <a:rPr dirty="0"/>
-              <a:t>, covered later), so the rest of the method runs as a scheduled Thread Pool work item, typically on a different thread. You will see the principal survive that switch, and then disappear inside a </a:t>
-            </a:r>
-            <a:r>
-              <a:rPr dirty="0" err="1"/>
-              <a:t>Task.Run</a:t>
-            </a:r>
-            <a:r>
-              <a:rPr dirty="0"/>
-              <a:t>(...) that was started with </a:t>
-            </a:r>
-            <a:r>
-              <a:rPr dirty="0" err="1"/>
-              <a:t>ExecutionContext</a:t>
-            </a:r>
-            <a:r>
-              <a:rPr dirty="0"/>
-              <a:t> flow suppressed.</a:t>
+              <a:t>Why this matters for the challenge: in "3. Principal" you sign in with your own name, and HomeController.RunExperiment() copies HttpContext.User into Thread.CurrentPrincipal, then awaits Task.Yield(). That await never completes synchronously (ConfigureAwaitOptions.ForceYielding, covered later, gives an awaited Task the same guarantee), so the rest of the method runs as a scheduled Thread Pool work item, typically on a different thread. The results table shows the principal survive that switch, flow into Task.Run(...), and come back null inside a Task.Run(...) that was started with ExecutionContext flow suppressed.</a:t>
             </a:r>
           </a:p>
           <a:p>

</xml_diff>

<commit_message>
Update Coding Challenges (#25)
* Update Coding Challenges

* Update Slides
</commit_message>
<xml_diff>
--- a/3. .NET Internals/Internals.pptx
+++ b/3. .NET Internals/Internals.pptx
@@ -839,7 +839,7 @@
           </a:p>
           <a:p>
             <a:r>
-              <a:t>We will look at five building blocks. The challenges follow the same order; AsyncLocal&lt;T&gt; is covered inside the ExecutionContext challenge:</a:t>
+              <a:t>We will look at five building blocks. The four steps of the InternalsLab challenge follow the same order; AsyncLocal&lt;T&gt; is covered inside Step 2, ExecutionContext:</a:t>
             </a:r>
           </a:p>
           <a:p>
@@ -849,12 +849,12 @@
           </a:p>
           <a:p>
             <a:r>
-              <a:t>2. AsyncLocal&lt;T&gt;: the same idea attached to the job instead of the thread, so the value follows your code across an await.</a:t>
-            </a:r>
-          </a:p>
-          <a:p>
-            <a:r>
-              <a:t>3. ExecutionContext: the container .NET uses to flow ambient data (AsyncLocal&lt;T&gt;, culture, principal) across threads, plus how to capture, run and suppress it.</a:t>
+              <a:t>2. ExecutionContext: the container .NET uses to flow ambient data (AsyncLocal&lt;T&gt;, culture, principal) across threads, plus how to capture, run and suppress it.</a:t>
+            </a:r>
+          </a:p>
+          <a:p>
+            <a:r>
+              <a:t>3. AsyncLocal&lt;T&gt;: the [ThreadStatic] idea attached to the job instead of the thread, so the value follows your code across an await.</a:t>
             </a:r>
           </a:p>
           <a:p>
@@ -1075,7 +1075,7 @@
           <a:lstStyle/>
           <a:p>
             <a:r>
-              <a:t>HttpContext is the per-request object in ASP.NET Core. Understanding how it is delivered to your code explains two of the four columns in the Principal challenge.</a:t>
+              <a:t>HttpContext is the per-request object in ASP.NET Core. Understanding how it is delivered to your code explains two of the four columns in Step 3, Principal.</a:t>
             </a:r>
           </a:p>
           <a:p>
@@ -1124,7 +1124,7 @@
           </a:p>
           <a:p>
             <a:r>
-              <a:t>Why this matters for the challenge: in the "3. Principal" results table the httpContextAccessor.HttpContext?.User column shows null at checkpoint 4 (the Task.Run started with flow suppressed) while the HttpContext.User column still shows your name. Same HttpContext object, two very different delivery mechanisms.</a:t>
+              <a:t>Why this matters for the challenge: in the Step 3 (Principal) results table the httpContextAccessor.HttpContext?.User column shows null at checkpoint 4 (the Task.Run started with flow suppressed) while the HttpContext.User column still shows your name. Same HttpContext object, two very different delivery mechanisms.</a:t>
             </a:r>
           </a:p>
           <a:p>
@@ -1380,7 +1380,7 @@
           <a:lstStyle/>
           <a:p>
             <a:r>
-              <a:t>Blazor Server is the one ASP.NET Core hosting model that DOES have a SynchronizationContext, and it is the setting for the last challenge.</a:t>
+              <a:t>Blazor Server is the one ASP.NET Core hosting model that DOES have a SynchronizationContext, and it is the setting for Step 4, the last step of the challenge.</a:t>
             </a:r>
           </a:p>
           <a:p>
@@ -1416,7 +1416,7 @@
           </a:p>
           <a:p>
             <a:r>
-              <a:t>Getting back onto the context: ComponentBase.InvokeAsync(...) dispatches a delegate through the renderer's Dispatcher. If you are already on the circuit's synchronization context it runs inline; otherwise it is queued behind the current work. In the HackerNews sample, after leaving the context with ConfigureAwait(false), every StateHasChanged() and every mutation of TopStoryCollection is wrapped in InvokeAsync(...) to get back on it.</a:t>
+              <a:t>Getting back onto the context: ComponentBase.InvokeAsync(...) dispatches a delegate through the renderer's Dispatcher. If you are already on the circuit's synchronization context it runs inline; otherwise it is queued behind the current work. In the finished HackerNews app from Correcting Common Async Await Mistakes, after leaving the context with ConfigureAwait(false), every StateHasChanged() and every mutation of TopStoryCollection is wrapped in InvokeAsync(...) to get back on it.</a:t>
             </a:r>
           </a:p>
           <a:p>
@@ -1424,7 +1424,7 @@
           </a:p>
           <a:p>
             <a:r>
-              <a:t>Why this matters for the challenge: in "4. SynchronizationContext" you should see a RendererSynchronizationContext before the first await, null after a ConfigureAwait(false) continuation, and the InvokeAsync(...) calls that marshal back for UI updates.</a:t>
+              <a:t>Why this matters for the challenge: in Step 4 (SynchronizationContext) you should see a RendererSynchronizationContext before the first await, null after a ConfigureAwait(false) continuation that had to wait, and RendererSynchronizationContext again inside the InvokeAsync(...) call that marshals back to change component state.</a:t>
             </a:r>
           </a:p>
           <a:p>
@@ -1716,7 +1716,7 @@
           </a:p>
           <a:p>
             <a:r>
-              <a:t>Practical takeaway: in single-threaded Blazor WebAssembly, ConfigureAwait(false) does not move you to another thread; there is not one. The same code in Blazor Server WILL leave the renderer's synchronization context. That is why the HackerNews challenge runs on Blazor Server, where the difference is observable. ConfigureAwait(false) itself is the next slide.</a:t>
+              <a:t>Practical takeaway: in single-threaded Blazor WebAssembly, ConfigureAwait(false) does not move you to another thread; there is not one. The same code in Blazor Server WILL leave the renderer's synchronization context. That is why the Step 4 experiment runs in Blazor Server, where the difference is observable. ConfigureAwait(false) itself is the next slide.</a:t>
             </a:r>
           </a:p>
           <a:p>
@@ -1724,7 +1724,7 @@
           </a:p>
           <a:p>
             <a:r>
-              <a:t>Not part of the challenges; included so you have the complete picture of where SynchronizationContext shows up across ASP.NET Core.</a:t>
+              <a:t>Not part of the challenge; included so you have the complete picture of where SynchronizationContext shows up across ASP.NET Core.</a:t>
             </a:r>
           </a:p>
         </p:txBody>
@@ -1959,7 +1959,7 @@
           </a:p>
           <a:p>
             <a:r>
-              <a:t>• Once you have left the context you must get back on your own before touching UI state. Blazor components use InvokeAsync(...) (ComponentBase.InvokeAsync, which goes through the renderer's Dispatcher); MAUI and WPF use Dispatcher / MainThread. In the HackerNews sample every StateHasChanged() and every mutation of TopStoryCollection is wrapped in InvokeAsync(...) for exactly this reason.</a:t>
+              <a:t>• Once you have left the context you must get back on your own before touching UI state. Blazor components use InvokeAsync(...) (ComponentBase.InvokeAsync, which goes through the renderer's Dispatcher); MAUI and WPF use Dispatcher / MainThread. In the finished HackerNews app from Correcting Common Async Await Mistakes, every StateHasChanged() and every mutation of TopStoryCollection is wrapped in InvokeAsync(...) for exactly this reason.</a:t>
             </a:r>
           </a:p>
           <a:p>
@@ -1975,7 +1975,7 @@
           </a:p>
           <a:p>
             <a:r>
-              <a:t>Why this matters for the challenge: in "4. SynchronizationContext" you set breakpoints before the first await and inside the await foreach loop after ConfigureAwait(false). Before: a Blazor RendererSynchronizationContext. After an asynchronous continuation: null, and typically a different thread. The other half of step 6 ("why may synchronous completion leave the current context unchanged?") is on the next slide.</a:t>
+              <a:t>Why this matters for the challenge: in Step 4 (SynchronizationContext) you predict SynchronizationContext.Current at six checkpoints in RefreshAsync(...), then run the experiment. Before the first await: a Blazor RendererSynchronizationContext. After ConfigureAwait(false) on a story that had to download: null, whether or not the thread changed. A plain await after that still reports null, because there was no context left to capture, and InvokeAsync(...) is what brings you back. The synchronous-completion part of README Step 4, item 4 ("why synchronous completion may leave the current context unchanged") is on the next slide.</a:t>
             </a:r>
           </a:p>
           <a:p>
@@ -2058,7 +2058,7 @@
           <a:lstStyle/>
           <a:p>
             <a:r>
-              <a:t>.NET 8 added an overload, task.ConfigureAwait(ConfigureAwaitOptions), a flags enum that replaces the true/false switch with independent knobs. The "4. SynchronizationContext" HackerNews sample uses it (ConfigureAwaitOptions.None | ConfigureAwaitOptions.SuppressThrowing), so let's decode it.</a:t>
+              <a:t>.NET 8 added an overload, task.ConfigureAwait(ConfigureAwaitOptions), a flags enum that replaces the true/false switch with independent knobs. The finished HackerNews app from Correcting Common Async Await Mistakes uses it (ConfigureAwaitOptions.None | ConfigureAwaitOptions.SuppressThrowing), so let's decode it.</a:t>
             </a:r>
           </a:p>
           <a:p>
@@ -2102,17 +2102,17 @@
           </a:p>
           <a:p>
             <a:r>
-              <a:t>In the samples:</a:t>
-            </a:r>
-          </a:p>
-          <a:p>
-            <a:r>
-              <a:t>• "3. Principal" needs the guarantee ForceYielding gives and gets it with await Task.Yield(), which never completes synchronously: checkpoint 2 always runs as a scheduled Thread Pool continuation rather than inline, so it typically lands on a different thread, which makes the Thread.CurrentPrincipal result meaningful.</a:t>
-            </a:r>
-          </a:p>
-          <a:p>
-            <a:r>
-              <a:t>• "4. SynchronizationContext" uses plain ConfigureAwait(false) for its Hacker News requests. If GetTopStoryIDs returns cached data, or a story request completes instantly, the continuation is synchronous and SynchronizationContext.Current may be unchanged, which is exactly what step 6 of the challenge asks you to explain.</a:t>
+              <a:t>In InternalsLab:</a:t>
+            </a:r>
+          </a:p>
+          <a:p>
+            <a:r>
+              <a:t>• Step 3 (Principal) needs the guarantee ForceYielding gives and gets it with await Task.Yield(), which never completes synchronously: checkpoint 2 always runs as a scheduled Thread Pool continuation rather than inline, so it typically lands on a different thread, which makes the Thread.CurrentPrincipal result meaningful.</a:t>
+            </a:r>
+          </a:p>
+          <a:p>
+            <a:r>
+              <a:t>• Step 4 (SynchronizationContext) uses plain ConfigureAwait(false) on its simulated story feed. The top story is already in SimulatedStoryFeed's cache, so GetStory returns a ValueTask that has already completed, the continuation is synchronous, and SynchronizationContext.Current at checkpoint 3 is unchanged, which is exactly what the second explain question on the Step 4 page (README Step 4, item 4) asks you to explain.</a:t>
             </a:r>
           </a:p>
           <a:p>
@@ -2195,7 +2195,7 @@
           <a:lstStyle/>
           <a:p>
             <a:r>
-              <a:t>This is the cheat sheet for all four challenges. Whenever a value is (or is not) available after an await, it falls into one of three buckets.</a:t>
+              <a:t>This is the cheat sheet for all four steps of the challenge. Whenever a value is (or is not) available after an await, it falls into one of three buckets.</a:t>
             </a:r>
           </a:p>
           <a:p>
@@ -2227,7 +2227,7 @@
           </a:p>
           <a:p>
             <a:r>
-              <a:t>Why this matters for the challenges: the "3. Principal" results table is designed around exactly these buckets. After the await at checkpoint 2, usually on a different thread, all four columns show your name. At checkpoint 4, inside Task.Run with flow suppressed, the two AsyncLocal-backed columns (Thread.CurrentPrincipal and httpContextAccessor.HttpContext?.User) show null, while HttpContext.User and the signedInUser local still show your name. Read the columns, not the rows.</a:t>
+              <a:t>Why this matters for the challenge: the Step 3 (Principal) results table is designed around exactly these buckets. After the await at checkpoint 2, usually on a different thread, all four columns show your name. At checkpoint 4, inside Task.Run with flow suppressed, the two AsyncLocal-backed columns (Thread.CurrentPrincipal and httpContextAccessor.HttpContext?.User) show null, while HttpContext.User and the signedInUser local still show your name. Read the columns, not the rows.</a:t>
             </a:r>
           </a:p>
           <a:p>
@@ -2364,7 +2364,7 @@
           </a:p>
           <a:p>
             <a:r>
-              <a:t>• Security concerns: thread-static data is dangerous on servers because threads are recycled. A Thread Pool thread that served request A will later serve request B, and any [ThreadStatic] data left behind is now visible to request B. Tasks also hop threads across an await, so a value set before the await may simply be gone afterwards. Prefer request-scoped state such as HttpContext, or something that flows with the operation (AsyncLocal&lt;T&gt;, next slide).</a:t>
+              <a:t>• Security concerns: thread-static data is dangerous on servers because threads are recycled. A Thread Pool thread that served request A will later serve request B, and any [ThreadStatic] data left behind is now visible to request B. Tasks also hop threads across an await, so a value set before the await may simply be gone afterwards. Prefer request-scoped state such as HttpContext, or something that flows with the operation (AsyncLocal&lt;T&gt;, covered right after the ExecutionContext slides).</a:t>
             </a:r>
           </a:p>
           <a:p>
@@ -2372,7 +2372,7 @@
           </a:p>
           <a:p>
             <a:r>
-              <a:t>Why this matters for the challenge: "1. ThreadStatic" is the baseline. You are proving to yourself that the data is bound to the THREAD. Every other topic in this module is about data that is bound to the logical OPERATION instead, so it can follow the operation across threads.</a:t>
+              <a:t>Why this matters for the challenge: Step 1 of InternalsLab, ThreadStatic, is the baseline. You are proving to yourself that the data is bound to the THREAD, which is why it stays behind when checkpoint 7 resumes on a Thread Pool thread after await Task.Yield(). Every other topic in this module is about data that is bound to the logical OPERATION instead, so it can follow the operation across threads.</a:t>
             </a:r>
           </a:p>
           <a:p>
@@ -2380,7 +2380,7 @@
           </a:p>
           <a:p>
             <a:r>
-              <a:t>Handy APIs in the sample: Environment.CurrentManagedThreadId is a cheap way to print which thread you are on. thread.Join() blocks the caller until that thread finishes, which is how the sample waits for both background threads before printing the main thread's value again.</a:t>
+              <a:t>Handy APIs in the sample: Environment.CurrentManagedThreadId is a cheap way to see which thread you are on; the lab notebook records it for every checkpoint in the Thread column. thread.Join() blocks the caller until that thread finishes, which is how the sample waits for both background threads before recording the main thread's value again at checkpoint 6.</a:t>
             </a:r>
           </a:p>
           <a:p>
@@ -2654,7 +2654,7 @@
           </a:p>
           <a:p>
             <a:r>
-              <a:t>• Stores data specific to a (logical) thread: in .NET Core everything inside it is an AsyncLocal&lt;T&gt; value.</a:t>
+              <a:t>• Stores + carries data across async hops: data specific to a (logical) thread, and in .NET Core everything inside it is an AsyncLocal&lt;T&gt; value.</a:t>
             </a:r>
           </a:p>
           <a:p>
@@ -2674,7 +2674,7 @@
           </a:p>
           <a:p>
             <a:r>
-              <a:t>  - History: in .NET Framework the ExecutionContext also carried the SynchronizationContext. In .NET Core / .NET 5+ it does NOT. The SynchronizationContext lives on the thread and is captured separately by the awaiter. That is why, in the last challenge, ConfigureAwait(false) drops the SynchronizationContext while the ExecutionContext keeps flowing.</a:t>
+              <a:t>  - History: in .NET Framework the ExecutionContext also carried the SynchronizationContext. In .NET Core / .NET 5+ it does NOT. The SynchronizationContext lives on the thread and is captured separately by the awaiter. That is why, in Step 4 of the challenge, ConfigureAwait(false) drops the SynchronizationContext while the ExecutionContext keeps flowing.</a:t>
             </a:r>
           </a:p>
           <a:p>
@@ -2697,7 +2697,7 @@
           </a:p>
           <a:p>
             <a:r>
-              <a:t>Why this matters for the challenge: in "2. ExecutionContext" you set a culture (es-ES), a principal and an AsyncLocal value on the main thread, then print them from a background Thread that assigns its own values, from ExecutionContext.Run(...) with the main thread's captured context (main thread values, same background thread), from Task.Run(...) (main thread values, flowed automatically) and from Task.Run(...) with flow suppressed (machine default culture, empty principal, empty AsyncLocal).</a:t>
+              <a:t>Why this matters for the challenge: in Step 2 of InternalsLab (ExecutionContext) the experiment sets a culture (es-ES), a principal and an AsyncLocal value on the main thread, then records them from a background Thread that assigns its own values, from ExecutionContext.Run(...) with the main thread's captured context (main thread values, same background thread), from Task.Run(...) (main thread values, flowed automatically) and from Task.Run(...) with flow suppressed (machine default culture, empty principal, empty AsyncLocal).</a:t>
             </a:r>
           </a:p>
           <a:p>
@@ -2955,7 +2955,7 @@
           </a:p>
           <a:p>
             <a:r>
-              <a:t>• Immutable snapshot: because contexts are copy-on-write, anything the callback sets is stored in a new context and discarded when Run returns. The caller's values are unchanged, which you can verify in the sample when "Main Thread Values" are printed again after the background thread finishes.</a:t>
+              <a:t>• Immutable snapshot: because contexts are copy-on-write, anything the callback sets is stored in a new context and discarded when Run returns. The caller's values are unchanged, which you can verify in the sample at checkpoint 4, when the main thread's values are recorded again after the background thread finishes.</a:t>
             </a:r>
           </a:p>
           <a:p>
@@ -2963,7 +2963,7 @@
           </a:p>
           <a:p>
             <a:r>
-              <a:t>Why this matters for the challenge: step 5 of "2. ExecutionContext" asks what changes when ExecutionContext.Run(...) is used. Answer: the thread is the same, but the ambient values are swapped for the ones in the captured snapshot, and swapped back afterwards. Step 6 asks what changes with Task.Run(...): the same thing happens, on a Thread Pool thread, without you writing any code.</a:t>
+              <a:t>Why this matters for the challenge: README Step 2, item 4 (the first explain question on the Step 2 page) asks what changes when ExecutionContext.Run(...) is used. Answer: the thread is the same, but the ambient values are swapped for the ones in the captured snapshot, and swapped back afterwards. Item 5 asks what changes when Task.Run(...) flows ExecutionContext automatically (checkpoint 5): the same thing happens, on a Thread Pool thread, without you writing any code.</a:t>
             </a:r>
           </a:p>
           <a:p>
@@ -3069,12 +3069,12 @@
           </a:p>
           <a:p>
             <a:r>
-              <a:t>• That constraint dictates the pattern you see in both samples: create the task INSIDE the using block, leave the block (flow is restored synchronously on the same thread), and only THEN await the task. If you awaited inside the using block, the continuation could resume on a different thread or with a different context, and the Dispose at the end of the block would throw.</a:t>
-            </a:r>
-          </a:p>
-          <a:p>
-            <a:r>
-              <a:t>• Inside the suppressed task every AsyncLocal-backed value is at its default: your AsyncLocal&lt;T&gt;.Value is null, Thread.CurrentPrincipal is null, IHttpContextAccessor.HttpContext is null, and CultureInfo.CurrentCulture is the machine default (for example "English (United States)") instead of the es-ES set on the main thread.</a:t>
+              <a:t>• That constraint dictates the pattern you see in the Step 2 and Step 3 experiments: create the task INSIDE the using block, leave the block (flow is restored synchronously on the same thread), and only THEN await the task. If you awaited inside the using block, the continuation could resume on a different thread or with a different context, and the Dispose at the end of the block would throw.</a:t>
+            </a:r>
+          </a:p>
+          <a:p>
+            <a:r>
+              <a:t>• Inside the suppressed task every AsyncLocal-backed value is at its default: your AsyncLocal&lt;T&gt;.Value is null, Thread.CurrentPrincipal is null, IHttpContextAccessor.HttpContext is null, and CultureInfo.CurrentCulture is the machine default (for example en-US) instead of the es-ES set on the main thread.</a:t>
             </a:r>
           </a:p>
           <a:p>
@@ -3100,7 +3100,7 @@
           </a:p>
           <a:p>
             <a:r>
-              <a:t>Why this matters for the challenges: steps 7 and 8 of "2. ExecutionContext" ("why does the suppressed task see default values?" and "why is the task awaited only after leaving the using block?") are answered by this slide, and so is checkpoint 4 in "3. Principal".</a:t>
+              <a:t>Why this matters for the challenge: README Step 2, items 6 and 7 ("why does the suppressed task see default values?" and "why is the task awaited only after leaving the using block?") are answered by this slide, and so is checkpoint 4 in Step 3 (Principal).</a:t>
             </a:r>
           </a:p>
           <a:p>
@@ -3221,7 +3221,7 @@
           </a:p>
           <a:p>
             <a:r>
-              <a:t>A picture that works in the room: a thread is a worker's desk, a job is a person carrying a backpack. [ThreadStatic] is a sticky note taped to the desk. After an await your job may resume at another desk, and the note stayed behind for the next job to find. AsyncLocal&lt;T&gt; is a sticky note inside the backpack. The backpack goes with the job from desk to desk, and every other job carries its own backpack. The next slide names the backpack: it is the ExecutionContext.</a:t>
+              <a:t>A picture that works in the room: a thread is a worker's desk, a job is a person carrying a backpack. [ThreadStatic] is a sticky note taped to the desk. After an await your job may resume at another desk, and the note stayed behind for the next job to find. AsyncLocal&lt;T&gt; is a sticky note inside the backpack. The backpack goes with the job from desk to desk, and every other job carries its own backpack. The backpack is the ExecutionContext, the "Digital Backpack" from the last three slides.</a:t>
             </a:r>
           </a:p>
           <a:p>
@@ -3234,7 +3234,7 @@
           </a:p>
           <a:p>
             <a:r>
-              <a:t>• One value per job, not per thread: assign _asyncLocalData.Value at the start of a job, then read it after an await that resumed on a Thread Pool thread, inside a Task.Run, or on a new Thread. It is still there. The thread changed; the job did not. Two jobs running at the same time each see their own value, even when they take turns on the same thread. Compare the previous slide, where a [ThreadStatic] value stays on the thread that assigned it.</a:t>
+              <a:t>• One value per job, not per thread: assign _asyncLocalData.Value at the start of a job, then read it after an await that resumed on a Thread Pool thread, inside a Task.Run, or on a new Thread. It is still there. The thread changed; the job did not. Two jobs running at the same time each see their own value, even when they take turns on the same thread. Compare the [ThreadStatic] slide, where a value stays on the thread that assigned it.</a:t>
             </a:r>
           </a:p>
           <a:p>
@@ -3244,12 +3244,12 @@
           </a:p>
           <a:p>
             <a:r>
-              <a:t>• Child work gets a copy: when a job starts more work (Task.Run, a new Thread, a Timer callback), the child gets a copy of the backpack. It sees the parent's value, and if it assigns a new one, only the child and the work the child starts see it. When control comes back to the parent, the parent still has its original value. That is the copy-on-write behaviour of ExecutionContext on the next slide. It is also why you assign the value at the START of a job (top of the request, beginning of the background job) rather than deep inside a helper while expecting the caller to see it.</a:t>
-            </a:r>
-          </a:p>
-          <a:p>
-            <a:r>
-              <a:t>• Carried by ExecutionContext: the backpack is the ExecutionContext, and in .NET Core AsyncLocal&lt;T&gt; is the only kind of note it holds. Thread.CurrentPrincipal, CultureInfo.CurrentCulture / CurrentUICulture and ASP.NET Core's IHttpContextAccessor.HttpContext are all AsyncLocal&lt;T&gt; fields underneath. That is why they behave exactly like your own AsyncLocal values in the next two challenges ("2. ExecutionContext" and "3. Principal"): they survive an await, they flow into Task.Run, and they are gone inside work started with ExecutionContext flow suppressed.</a:t>
+              <a:t>• Child work gets a copy: when a job starts more work (Task.Run, a new Thread, a Timer callback), the child gets a copy of the backpack. It sees the parent's value, and if it assigns a new one, only the child and the work the child starts see it. When control comes back to the parent, the parent still has its original value. That is the copy-on-write behaviour of ExecutionContext from the earlier slides. It is also why you assign the value at the START of a job (top of the request, beginning of the background job) rather than deep inside a helper while expecting the caller to see it.</a:t>
+            </a:r>
+          </a:p>
+          <a:p>
+            <a:r>
+              <a:t>• Examples (Principal, Culture and IHttpContextAccessor): the backpack is the ExecutionContext, and in .NET Core AsyncLocal&lt;T&gt; is the only kind of note it holds. Thread.CurrentPrincipal, CultureInfo.CurrentCulture / CurrentUICulture and ASP.NET Core's IHttpContextAccessor.HttpContext are all AsyncLocal&lt;T&gt; fields underneath. That is why they behave exactly like your own AsyncLocal values in Steps 2 and 3 of the challenge (ExecutionContext and Principal): they survive an await, they flow into Task.Run, and they are gone inside work started with ExecutionContext flow suppressed.</a:t>
             </a:r>
           </a:p>
           <a:p>
@@ -3275,7 +3275,7 @@
           </a:p>
           <a:p>
             <a:r>
-              <a:t>Why this matters for the challenge: in "2. ExecutionContext" the main thread assigns _asyncLocalData.Value = "Initial Value". Predict what PrintThreadValues() prints for AsyncLocalData at each call: on the main thread right after the assignment ("Initial Value"), on the background Thread after it assigns its own value ("AsyncLocalData in Thread": it started with a copy of the main thread's backpack and wrote on its copy), inside ExecutionContext.Run(...) with the main thread's captured context ("Initial Value": the main thread's backpack was handed to that thread, so the backpack wins, not the thread), back on the main thread after Join() ("Initial Value": the thread wrote on its own copy, so nothing came back), inside Task.Run(...) ("Initial Value": the copy travelled automatically) and inside Task.Run(...) with flow suppressed (empty: it was handed an empty backpack). The next three slides are the "how" behind each of those.</a:t>
+              <a:t>Why this matters for the challenge: in Step 2 (ExecutionContext) the main thread assigns _asyncLocalData.Value = "Initial Value". Predict what RecordThreadValues(int) records for _asyncLocalData.Value at each checkpoint: on the main thread right after the assignment ("Initial Value"), on the background Thread after it assigns its own value ("AsyncLocalData in Thread": it started with a copy of the main thread's backpack and wrote on its copy), inside ExecutionContext.Run(...) with the main thread's captured context ("Initial Value": the main thread's backpack was handed to that thread, so the backpack wins, not the thread), back on the main thread after Join() ("Initial Value": the thread wrote on its own copy, so nothing came back), inside Task.Run(...) ("Initial Value": the copy travelled automatically) and inside Task.Run(...) with flow suppressed (empty: it was handed an empty backpack). The three ExecutionContext slides before this one are the "how" behind each of those.</a:t>
             </a:r>
           </a:p>
           <a:p>
@@ -3597,7 +3597,7 @@
           <a:p>
             <a:r>
               <a:rPr dirty="0"/>
-              <a:t>Why this matters for the challenge: in "3. Principal" you sign in with your own name, and HomeController.RunExperiment() copies HttpContext.User into Thread.CurrentPrincipal, then awaits Task.Yield(). That await never completes synchronously (ConfigureAwaitOptions.ForceYielding, covered later, gives an awaited Task the same guarantee), so the rest of the method runs as a scheduled Thread Pool work item, typically on a different thread. The results table shows the principal survive that switch, flow into Task.Run(...), and come back null inside a Task.Run(...) that was started with ExecutionContext flow suppressed.</a:t>
+              <a:t>Why this matters for the challenge: in Step 3 (Principal) you sign in with your own name, and PrincipalController.RunExperiment() copies HttpContext.User into Thread.CurrentPrincipal, then awaits Task.Yield(). That await never completes synchronously (ConfigureAwaitOptions.ForceYielding, covered later, gives an awaited Task the same guarantee), so the rest of the method runs as a scheduled Thread Pool work item, typically on a different thread. The results table shows the principal survive that switch, flow into Task.Run(...), and come back null inside a Task.Run(...) that was started with ExecutionContext flow suppressed.</a:t>
             </a:r>
           </a:p>
           <a:p>

</xml_diff>